<commit_message>
Videos propios de nuevo: la presentacion muestra el mismo video que el visor
Los videos de 02.2, 16.5, 17.1 y 19.1 vuelven a ser los nuestros (se habian
reemplazado por las versiones del sitio de Protobject). Sus presentaciones y la
del 16.2 (sol 5x5) se regeneran; --force vuelve a tomar la foto del programa.

Co-Authored-By: Claude Opus 5 <noreply@anthropic.com>
</commit_message>
<xml_diff>
--- a/ppt/17.1-magic-clap-switch.es.pptx
+++ b/ppt/17.1-magic-clap-switch.es.pptx
@@ -4765,8 +4765,8 @@
         </p:blipFill>
         <p:spPr>
           <a:xfrm>
-            <a:off x="1441138" y="1232015"/>
-            <a:ext cx="9331959" cy="5249226"/>
+            <a:off x="4611414" y="1197600"/>
+            <a:ext cx="2991407" cy="5318057"/>
           </a:xfrm>
           <a:prstGeom prst="rect">
             <a:avLst/>

</xml_diff>